<commit_message>
Deck: slide 6 orange panel as a right-half shape (viewers blended the 50% hard-stop gradient across the slide)
Co-Authored-By: Claude Opus 5.5 <noreply@anthropic.com>
</commit_message>
<xml_diff>
--- a/docs/pitch/PatchPilot_final.pptx
+++ b/docs/pitch/PatchPilot_final.pptx
@@ -8270,8 +8270,8 @@
         </p:nvSpPr>
         <p:spPr>
           <a:xfrm>
-            <a:off x="0" y="0"/>
-            <a:ext cx="12192000" cy="6858000"/>
+            <a:off x="6096000" y="0"/>
+            <a:ext cx="6096000" cy="6858000"/>
           </a:xfrm>
           <a:prstGeom prst="rect">
             <a:avLst/>
@@ -8279,12 +8279,6 @@
           <a:gradFill rotWithShape="1">
             <a:gsLst>
               <a:gs pos="0">
-                <a:srgbClr val="0E0B09"/>
-              </a:gs>
-              <a:gs pos="50000">
-                <a:srgbClr val="0E0B09"/>
-              </a:gs>
-              <a:gs pos="50000">
                 <a:srgbClr val="E8652B"/>
               </a:gs>
               <a:gs pos="100000">

</xml_diff>

<commit_message>
Deck: slide 3 lists 6 key features (incl. SupplyGuard dependency check, safe upgrades + SBOM/SARIF) beside the real-run screenshots
Co-Authored-By: Claude Opus 5.5 <noreply@anthropic.com>
</commit_message>
<xml_diff>
--- a/docs/pitch/PatchPilot_final.pptx
+++ b/docs/pitch/PatchPilot_final.pptx
@@ -915,19 +915,25 @@
           <a:p>
             <a:r>
               <a:rPr lang="en-US" dirty="0"/>
+              <a:t>Right side, the six things that make it trustworthy: proof, the SupplyGuard dependency check before install, safe upgrades with SBOM/SARIF reports, the locked-down sandbox, checks the AI cannot fake, and you approving the exact diff. The orange numbers on the screenshots match.</a:t>
+            </a:r>
+          </a:p>
+          <a:p>
+            <a:r>
+              <a:rPr lang="en-US" dirty="0"/>
               <a:t>1: the new test fails twice on the original code and passes twice after the fix, in a fresh sandbox.</a:t>
             </a:r>
           </a:p>
           <a:p>
             <a:r>
               <a:rPr lang="en-US" dirty="0"/>
-              <a:t>2: the fix also passes a hidden variant of the test that the Fixer never saw, so it can't just special-case the test.</a:t>
+              <a:t>5: the fix also passes a hidden variant of the test that the Fixer never saw, so it can't just special-case the test.</a:t>
             </a:r>
           </a:p>
           <a:p>
             <a:r>
               <a:rPr lang="en-US" dirty="0"/>
-              <a:t>3: nothing is published until a human reads and approves this exact diff.</a:t>
+              <a:t>6: nothing is published until a human reads and approves this exact diff.</a:t>
             </a:r>
           </a:p>
         </p:txBody>
@@ -7577,8 +7583,8 @@
         </p:blipFill>
         <p:spPr>
           <a:xfrm>
-            <a:off x="812800" y="2300000"/>
-            <a:ext cx="3289173" cy="3000000"/>
+            <a:off x="812800" y="2250000"/>
+            <a:ext cx="2631338" cy="2400000"/>
           </a:xfrm>
           <a:prstGeom prst="roundRect">
             <a:avLst>
@@ -7607,8 +7613,8 @@
         </p:blipFill>
         <p:spPr>
           <a:xfrm>
-            <a:off x="4351973" y="2300000"/>
-            <a:ext cx="3555555" cy="3000000"/>
+            <a:off x="3644138" y="2250000"/>
+            <a:ext cx="2844444" cy="2400000"/>
           </a:xfrm>
           <a:prstGeom prst="roundRect">
             <a:avLst>
@@ -7630,29 +7636,29 @@
         </p:nvSpPr>
         <p:spPr>
           <a:xfrm>
-            <a:off x="812800" y="1970000"/>
-            <a:ext cx="7600000" cy="230000"/>
-          </a:xfrm>
-          <a:prstGeom prst="rect">
-            <a:avLst/>
-          </a:prstGeom>
-          <a:noFill/>
-          <a:ln/>
-        </p:spPr>
-        <p:txBody>
-          <a:bodyPr wrap="square" lIns="0" tIns="0" rIns="0" bIns="0" rtlCol="0" anchor="t">
-            <a:normAutofit/>
-          </a:bodyPr>
-          <a:lstStyle/>
-          <a:p>
-            <a:pPr algn="l" indent="0" marL="0">
-              <a:lnSpc>
-                <a:spcPts val="1400"/>
-              </a:lnSpc>
-              <a:buNone/>
-            </a:pPr>
-            <a:r>
-              <a:rPr lang="en-US" sz="1100" dirty="0">
+            <a:off x="812800" y="1920000"/>
+            <a:ext cx="5675782" cy="230000"/>
+          </a:xfrm>
+          <a:prstGeom prst="rect">
+            <a:avLst/>
+          </a:prstGeom>
+          <a:noFill/>
+          <a:ln/>
+        </p:spPr>
+        <p:txBody>
+          <a:bodyPr wrap="square" lIns="0" tIns="0" rIns="0" bIns="0" rtlCol="0" anchor="t">
+            <a:normAutofit/>
+          </a:bodyPr>
+          <a:lstStyle/>
+          <a:p>
+            <a:pPr algn="l" indent="0" marL="0">
+              <a:lnSpc>
+                <a:spcPts val="1300"/>
+              </a:lnSpc>
+              <a:buNone/>
+            </a:pPr>
+            <a:r>
+              <a:rPr lang="en-US" sz="1050" dirty="0">
                 <a:solidFill>
                   <a:srgbClr val="A89C92"/>
                 </a:solidFill>
@@ -7660,9 +7666,9 @@
                 <a:ea typeface="JetBrains Mono" pitchFamily="49" charset="-122"/>
                 <a:cs typeface="JetBrains Mono" pitchFamily="49" charset="-120"/>
               </a:rPr>
-              <a:t>Live run · a planted bug in our demo repo (tinycalc #1), fixed and verified</a:t>
-            </a:r>
-            <a:endParaRPr lang="en-US" sz="1100" dirty="0"/>
+              <a:t>Live run on tinycalc #1, a planted bug in our demo repo</a:t>
+            </a:r>
+            <a:endParaRPr lang="en-US" sz="1050" dirty="0"/>
           </a:p>
         </p:txBody>
       </p:sp>
@@ -7674,8 +7680,8 @@
         </p:nvSpPr>
         <p:spPr>
           <a:xfrm>
-            <a:off x="3739622" y="3179000"/>
-            <a:ext cx="330000" cy="330000"/>
+            <a:off x="3136257" y="2935200"/>
+            <a:ext cx="300000" cy="300000"/>
           </a:xfrm>
           <a:prstGeom prst="ellipse">
             <a:avLst/>
@@ -7697,12 +7703,12 @@
           <a:p>
             <a:pPr algn="ctr" indent="0" marL="0">
               <a:lnSpc>
-                <a:spcPts val="1560"/>
-              </a:lnSpc>
-              <a:buNone/>
-            </a:pPr>
-            <a:r>
-              <a:rPr lang="en-US" sz="1300" dirty="0" b="1">
+                <a:spcPts val="1440"/>
+              </a:lnSpc>
+              <a:buNone/>
+            </a:pPr>
+            <a:r>
+              <a:rPr lang="en-US" sz="1200" dirty="0" b="1">
                 <a:solidFill>
                   <a:srgbClr val="F2EDE8"/>
                 </a:solidFill>
@@ -7712,7 +7718,7 @@
               </a:rPr>
               <a:t>1</a:t>
             </a:r>
-            <a:endParaRPr lang="en-US" sz="1300" dirty="0"/>
+            <a:endParaRPr lang="en-US" sz="1200" dirty="0"/>
           </a:p>
         </p:txBody>
       </p:sp>
@@ -7724,8 +7730,8 @@
         </p:nvSpPr>
         <p:spPr>
           <a:xfrm>
-            <a:off x="3877767" y="4415000"/>
-            <a:ext cx="330000" cy="330000"/>
+            <a:off x="3246773" y="3924000"/>
+            <a:ext cx="300000" cy="300000"/>
           </a:xfrm>
           <a:prstGeom prst="ellipse">
             <a:avLst/>
@@ -7747,12 +7753,12 @@
           <a:p>
             <a:pPr algn="ctr" indent="0" marL="0">
               <a:lnSpc>
-                <a:spcPts val="1560"/>
-              </a:lnSpc>
-              <a:buNone/>
-            </a:pPr>
-            <a:r>
-              <a:rPr lang="en-US" sz="1300" dirty="0" b="1">
+                <a:spcPts val="1440"/>
+              </a:lnSpc>
+              <a:buNone/>
+            </a:pPr>
+            <a:r>
+              <a:rPr lang="en-US" sz="1200" dirty="0" b="1">
                 <a:solidFill>
                   <a:srgbClr val="F2EDE8"/>
                 </a:solidFill>
@@ -7760,9 +7766,9 @@
                 <a:ea typeface="Inter" pitchFamily="34" charset="-122"/>
                 <a:cs typeface="Inter" pitchFamily="34" charset="-120"/>
               </a:rPr>
-              <a:t>2</a:t>
-            </a:r>
-            <a:endParaRPr lang="en-US" sz="1300" dirty="0"/>
+              <a:t>5</a:t>
+            </a:r>
+            <a:endParaRPr lang="en-US" sz="1200" dirty="0"/>
           </a:p>
         </p:txBody>
       </p:sp>
@@ -7774,8 +7780,8 @@
         </p:nvSpPr>
         <p:spPr>
           <a:xfrm>
-            <a:off x="7678528" y="2180000"/>
-            <a:ext cx="330000" cy="330000"/>
+            <a:off x="6287382" y="2136000"/>
+            <a:ext cx="300000" cy="300000"/>
           </a:xfrm>
           <a:prstGeom prst="ellipse">
             <a:avLst/>
@@ -7797,12 +7803,12 @@
           <a:p>
             <a:pPr algn="ctr" indent="0" marL="0">
               <a:lnSpc>
-                <a:spcPts val="1560"/>
-              </a:lnSpc>
-              <a:buNone/>
-            </a:pPr>
-            <a:r>
-              <a:rPr lang="en-US" sz="1300" dirty="0" b="1">
+                <a:spcPts val="1440"/>
+              </a:lnSpc>
+              <a:buNone/>
+            </a:pPr>
+            <a:r>
+              <a:rPr lang="en-US" sz="1200" dirty="0" b="1">
                 <a:solidFill>
                   <a:srgbClr val="F2EDE8"/>
                 </a:solidFill>
@@ -7810,9 +7816,9 @@
                 <a:ea typeface="Inter" pitchFamily="34" charset="-122"/>
                 <a:cs typeface="Inter" pitchFamily="34" charset="-120"/>
               </a:rPr>
-              <a:t>3</a:t>
-            </a:r>
-            <a:endParaRPr lang="en-US" sz="1300" dirty="0"/>
+              <a:t>6</a:t>
+            </a:r>
+            <a:endParaRPr lang="en-US" sz="1200" dirty="0"/>
           </a:p>
         </p:txBody>
       </p:sp>
@@ -7824,8 +7830,8 @@
         </p:nvSpPr>
         <p:spPr>
           <a:xfrm>
-            <a:off x="8287528" y="2320000"/>
-            <a:ext cx="330000" cy="330000"/>
+            <a:off x="6938582" y="1830000"/>
+            <a:ext cx="300000" cy="300000"/>
           </a:xfrm>
           <a:prstGeom prst="ellipse">
             <a:avLst/>
@@ -7847,12 +7853,12 @@
           <a:p>
             <a:pPr algn="ctr" indent="0" marL="0">
               <a:lnSpc>
-                <a:spcPts val="1560"/>
-              </a:lnSpc>
-              <a:buNone/>
-            </a:pPr>
-            <a:r>
-              <a:rPr lang="en-US" sz="1300" dirty="0" b="1">
+                <a:spcPts val="1440"/>
+              </a:lnSpc>
+              <a:buNone/>
+            </a:pPr>
+            <a:r>
+              <a:rPr lang="en-US" sz="1200" dirty="0" b="1">
                 <a:solidFill>
                   <a:srgbClr val="F2EDE8"/>
                 </a:solidFill>
@@ -7862,7 +7868,7 @@
               </a:rPr>
               <a:t>1</a:t>
             </a:r>
-            <a:endParaRPr lang="en-US" sz="1300" dirty="0"/>
+            <a:endParaRPr lang="en-US" sz="1200" dirty="0"/>
           </a:p>
         </p:txBody>
       </p:sp>
@@ -7874,29 +7880,29 @@
         </p:nvSpPr>
         <p:spPr>
           <a:xfrm>
-            <a:off x="8757528" y="2300000"/>
-            <a:ext cx="2621672" cy="624200"/>
-          </a:xfrm>
-          <a:prstGeom prst="rect">
-            <a:avLst/>
-          </a:prstGeom>
-          <a:noFill/>
-          <a:ln/>
-        </p:spPr>
-        <p:txBody>
-          <a:bodyPr wrap="square" lIns="0" tIns="0" rIns="0" bIns="0" rtlCol="0" anchor="t">
-            <a:normAutofit/>
-          </a:bodyPr>
-          <a:lstStyle/>
-          <a:p>
-            <a:pPr algn="l" indent="0" marL="0">
-              <a:lnSpc>
-                <a:spcPts val="2300"/>
-              </a:lnSpc>
-              <a:buNone/>
-            </a:pPr>
-            <a:r>
-              <a:rPr lang="en-US" sz="1800" dirty="0" b="0">
+            <a:off x="7358582" y="1820000"/>
+            <a:ext cx="4020618" cy="260000"/>
+          </a:xfrm>
+          <a:prstGeom prst="rect">
+            <a:avLst/>
+          </a:prstGeom>
+          <a:noFill/>
+          <a:ln/>
+        </p:spPr>
+        <p:txBody>
+          <a:bodyPr wrap="square" lIns="0" tIns="0" rIns="0" bIns="0" rtlCol="0" anchor="t">
+            <a:normAutofit/>
+          </a:bodyPr>
+          <a:lstStyle/>
+          <a:p>
+            <a:pPr algn="l" indent="0" marL="0">
+              <a:lnSpc>
+                <a:spcPts val="1600"/>
+              </a:lnSpc>
+              <a:buNone/>
+            </a:pPr>
+            <a:r>
+              <a:rPr lang="en-US" sz="1350" dirty="0" b="1">
                 <a:solidFill>
                   <a:srgbClr val="F2EDE8"/>
                 </a:solidFill>
@@ -7904,9 +7910,9 @@
                 <a:ea typeface="Inter" pitchFamily="34" charset="-122"/>
                 <a:cs typeface="Inter" pitchFamily="34" charset="-120"/>
               </a:rPr>
-              <a:t>Fails 2/2 before. Passes 2/2 after.</a:t>
-            </a:r>
-            <a:endParaRPr lang="en-US" sz="1800" dirty="0"/>
+              <a:t>Proof, not promises</a:t>
+            </a:r>
+            <a:endParaRPr lang="en-US" sz="1350" dirty="0"/>
           </a:p>
         </p:txBody>
       </p:sp>
@@ -7918,8 +7924,52 @@
         </p:nvSpPr>
         <p:spPr>
           <a:xfrm>
-            <a:off x="8287528" y="3154200"/>
-            <a:ext cx="330000" cy="330000"/>
+            <a:off x="7358582" y="2070000"/>
+            <a:ext cx="4020618" cy="420000"/>
+          </a:xfrm>
+          <a:prstGeom prst="rect">
+            <a:avLst/>
+          </a:prstGeom>
+          <a:noFill/>
+          <a:ln/>
+        </p:spPr>
+        <p:txBody>
+          <a:bodyPr wrap="square" lIns="0" tIns="0" rIns="0" bIns="0" rtlCol="0" anchor="t">
+            <a:normAutofit/>
+          </a:bodyPr>
+          <a:lstStyle/>
+          <a:p>
+            <a:pPr algn="l" indent="0" marL="0">
+              <a:lnSpc>
+                <a:spcPts val="1250"/>
+              </a:lnSpc>
+              <a:buNone/>
+            </a:pPr>
+            <a:r>
+              <a:rPr lang="en-US" sz="1000" dirty="0" b="0">
+                <a:solidFill>
+                  <a:srgbClr val="A89C92"/>
+                </a:solidFill>
+                <a:latin typeface="Inter" pitchFamily="34" charset="0"/>
+                <a:ea typeface="Inter" pitchFamily="34" charset="-122"/>
+                <a:cs typeface="Inter" pitchFamily="34" charset="-120"/>
+              </a:rPr>
+              <a:t>The same new test fails 2/2 on the original code, then passes 2/2 after the fix in a fresh sandbox.</a:t>
+            </a:r>
+            <a:endParaRPr lang="en-US" sz="1000" dirty="0"/>
+          </a:p>
+        </p:txBody>
+      </p:sp>
+      <p:sp>
+        <p:nvSpPr>
+          <p:cNvPr id="50" name="Text 5 copy 50"/>
+          <p:cNvSpPr/>
+          <p:nvPr/>
+        </p:nvSpPr>
+        <p:spPr>
+          <a:xfrm>
+            <a:off x="6938582" y="2520000"/>
+            <a:ext cx="300000" cy="300000"/>
           </a:xfrm>
           <a:prstGeom prst="ellipse">
             <a:avLst/>
@@ -7941,12 +7991,12 @@
           <a:p>
             <a:pPr algn="ctr" indent="0" marL="0">
               <a:lnSpc>
-                <a:spcPts val="1560"/>
-              </a:lnSpc>
-              <a:buNone/>
-            </a:pPr>
-            <a:r>
-              <a:rPr lang="en-US" sz="1300" dirty="0" b="1">
+                <a:spcPts val="1440"/>
+              </a:lnSpc>
+              <a:buNone/>
+            </a:pPr>
+            <a:r>
+              <a:rPr lang="en-US" sz="1200" dirty="0" b="1">
                 <a:solidFill>
                   <a:srgbClr val="F2EDE8"/>
                 </a:solidFill>
@@ -7956,41 +8006,41 @@
               </a:rPr>
               <a:t>2</a:t>
             </a:r>
-            <a:endParaRPr lang="en-US" sz="1300" dirty="0"/>
-          </a:p>
-        </p:txBody>
-      </p:sp>
-      <p:sp>
-        <p:nvSpPr>
-          <p:cNvPr id="50" name="Text 5 copy 50"/>
-          <p:cNvSpPr/>
-          <p:nvPr/>
-        </p:nvSpPr>
-        <p:spPr>
-          <a:xfrm>
-            <a:off x="8757528" y="3134200"/>
-            <a:ext cx="2621672" cy="916300"/>
-          </a:xfrm>
-          <a:prstGeom prst="rect">
-            <a:avLst/>
-          </a:prstGeom>
-          <a:noFill/>
-          <a:ln/>
-        </p:spPr>
-        <p:txBody>
-          <a:bodyPr wrap="square" lIns="0" tIns="0" rIns="0" bIns="0" rtlCol="0" anchor="t">
-            <a:normAutofit/>
-          </a:bodyPr>
-          <a:lstStyle/>
-          <a:p>
-            <a:pPr algn="l" indent="0" marL="0">
-              <a:lnSpc>
-                <a:spcPts val="2300"/>
-              </a:lnSpc>
-              <a:buNone/>
-            </a:pPr>
-            <a:r>
-              <a:rPr lang="en-US" sz="1800" dirty="0" b="0">
+            <a:endParaRPr lang="en-US" sz="1200" dirty="0"/>
+          </a:p>
+        </p:txBody>
+      </p:sp>
+      <p:sp>
+        <p:nvSpPr>
+          <p:cNvPr id="51" name="Text 5 copy 51"/>
+          <p:cNvSpPr/>
+          <p:nvPr/>
+        </p:nvSpPr>
+        <p:spPr>
+          <a:xfrm>
+            <a:off x="7358582" y="2510000"/>
+            <a:ext cx="4020618" cy="260000"/>
+          </a:xfrm>
+          <a:prstGeom prst="rect">
+            <a:avLst/>
+          </a:prstGeom>
+          <a:noFill/>
+          <a:ln/>
+        </p:spPr>
+        <p:txBody>
+          <a:bodyPr wrap="square" lIns="0" tIns="0" rIns="0" bIns="0" rtlCol="0" anchor="t">
+            <a:normAutofit/>
+          </a:bodyPr>
+          <a:lstStyle/>
+          <a:p>
+            <a:pPr algn="l" indent="0" marL="0">
+              <a:lnSpc>
+                <a:spcPts val="1600"/>
+              </a:lnSpc>
+              <a:buNone/>
+            </a:pPr>
+            <a:r>
+              <a:rPr lang="en-US" sz="1350" dirty="0" b="1">
                 <a:solidFill>
                   <a:srgbClr val="F2EDE8"/>
                 </a:solidFill>
@@ -7998,22 +8048,66 @@
                 <a:ea typeface="Inter" pitchFamily="34" charset="-122"/>
                 <a:cs typeface="Inter" pitchFamily="34" charset="-120"/>
               </a:rPr>
-              <a:t>Also passes a hidden test the fixer never saw.</a:t>
-            </a:r>
-            <a:endParaRPr lang="en-US" sz="1800" dirty="0"/>
-          </a:p>
-        </p:txBody>
-      </p:sp>
-      <p:sp>
-        <p:nvSpPr>
-          <p:cNvPr id="51" name="Text 5 copy 51"/>
-          <p:cNvSpPr/>
-          <p:nvPr/>
-        </p:nvSpPr>
-        <p:spPr>
-          <a:xfrm>
-            <a:off x="8287528" y="4280500"/>
-            <a:ext cx="330000" cy="330000"/>
+              <a:t>Dependency check before install</a:t>
+            </a:r>
+            <a:endParaRPr lang="en-US" sz="1350" dirty="0"/>
+          </a:p>
+        </p:txBody>
+      </p:sp>
+      <p:sp>
+        <p:nvSpPr>
+          <p:cNvPr id="52" name="Text 5 copy 52"/>
+          <p:cNvSpPr/>
+          <p:nvPr/>
+        </p:nvSpPr>
+        <p:spPr>
+          <a:xfrm>
+            <a:off x="7358582" y="2760000"/>
+            <a:ext cx="4020618" cy="420000"/>
+          </a:xfrm>
+          <a:prstGeom prst="rect">
+            <a:avLst/>
+          </a:prstGeom>
+          <a:noFill/>
+          <a:ln/>
+        </p:spPr>
+        <p:txBody>
+          <a:bodyPr wrap="square" lIns="0" tIns="0" rIns="0" bIns="0" rtlCol="0" anchor="t">
+            <a:normAutofit/>
+          </a:bodyPr>
+          <a:lstStyle/>
+          <a:p>
+            <a:pPr algn="l" indent="0" marL="0">
+              <a:lnSpc>
+                <a:spcPts val="1250"/>
+              </a:lnSpc>
+              <a:buNone/>
+            </a:pPr>
+            <a:r>
+              <a:rPr lang="en-US" sz="1000" dirty="0" b="0">
+                <a:solidFill>
+                  <a:srgbClr val="A89C92"/>
+                </a:solidFill>
+                <a:latin typeface="Inter" pitchFamily="34" charset="0"/>
+                <a:ea typeface="Inter" pitchFamily="34" charset="-122"/>
+                <a:cs typeface="Inter" pitchFamily="34" charset="-120"/>
+              </a:rPr>
+              <a:t>Our own scanner, SupplyGuard, checks every lock file for vulnerabilities and fake packages. A malicious one stops the run.</a:t>
+            </a:r>
+            <a:endParaRPr lang="en-US" sz="1000" dirty="0"/>
+          </a:p>
+        </p:txBody>
+      </p:sp>
+      <p:sp>
+        <p:nvSpPr>
+          <p:cNvPr id="53" name="Text 5 copy 53"/>
+          <p:cNvSpPr/>
+          <p:nvPr/>
+        </p:nvSpPr>
+        <p:spPr>
+          <a:xfrm>
+            <a:off x="6938582" y="3210000"/>
+            <a:ext cx="300000" cy="300000"/>
           </a:xfrm>
           <a:prstGeom prst="ellipse">
             <a:avLst/>
@@ -8035,12 +8129,12 @@
           <a:p>
             <a:pPr algn="ctr" indent="0" marL="0">
               <a:lnSpc>
-                <a:spcPts val="1560"/>
-              </a:lnSpc>
-              <a:buNone/>
-            </a:pPr>
-            <a:r>
-              <a:rPr lang="en-US" sz="1300" dirty="0" b="1">
+                <a:spcPts val="1440"/>
+              </a:lnSpc>
+              <a:buNone/>
+            </a:pPr>
+            <a:r>
+              <a:rPr lang="en-US" sz="1200" dirty="0" b="1">
                 <a:solidFill>
                   <a:srgbClr val="F2EDE8"/>
                 </a:solidFill>
@@ -8050,41 +8144,41 @@
               </a:rPr>
               <a:t>3</a:t>
             </a:r>
-            <a:endParaRPr lang="en-US" sz="1300" dirty="0"/>
-          </a:p>
-        </p:txBody>
-      </p:sp>
-      <p:sp>
-        <p:nvSpPr>
-          <p:cNvPr id="52" name="Text 5 copy 52"/>
-          <p:cNvSpPr/>
-          <p:nvPr/>
-        </p:nvSpPr>
-        <p:spPr>
-          <a:xfrm>
-            <a:off x="8757528" y="4260500"/>
-            <a:ext cx="2621672" cy="916300"/>
-          </a:xfrm>
-          <a:prstGeom prst="rect">
-            <a:avLst/>
-          </a:prstGeom>
-          <a:noFill/>
-          <a:ln/>
-        </p:spPr>
-        <p:txBody>
-          <a:bodyPr wrap="square" lIns="0" tIns="0" rIns="0" bIns="0" rtlCol="0" anchor="t">
-            <a:normAutofit/>
-          </a:bodyPr>
-          <a:lstStyle/>
-          <a:p>
-            <a:pPr algn="l" indent="0" marL="0">
-              <a:lnSpc>
-                <a:spcPts val="2300"/>
-              </a:lnSpc>
-              <a:buNone/>
-            </a:pPr>
-            <a:r>
-              <a:rPr lang="en-US" sz="1800" dirty="0" b="0">
+            <a:endParaRPr lang="en-US" sz="1200" dirty="0"/>
+          </a:p>
+        </p:txBody>
+      </p:sp>
+      <p:sp>
+        <p:nvSpPr>
+          <p:cNvPr id="54" name="Text 5 copy 54"/>
+          <p:cNvSpPr/>
+          <p:nvPr/>
+        </p:nvSpPr>
+        <p:spPr>
+          <a:xfrm>
+            <a:off x="7358582" y="3200000"/>
+            <a:ext cx="4020618" cy="260000"/>
+          </a:xfrm>
+          <a:prstGeom prst="rect">
+            <a:avLst/>
+          </a:prstGeom>
+          <a:noFill/>
+          <a:ln/>
+        </p:spPr>
+        <p:txBody>
+          <a:bodyPr wrap="square" lIns="0" tIns="0" rIns="0" bIns="0" rtlCol="0" anchor="t">
+            <a:normAutofit/>
+          </a:bodyPr>
+          <a:lstStyle/>
+          <a:p>
+            <a:pPr algn="l" indent="0" marL="0">
+              <a:lnSpc>
+                <a:spcPts val="1600"/>
+              </a:lnSpc>
+              <a:buNone/>
+            </a:pPr>
+            <a:r>
+              <a:rPr lang="en-US" sz="1350" dirty="0" b="1">
                 <a:solidFill>
                   <a:srgbClr val="F2EDE8"/>
                 </a:solidFill>
@@ -8092,43 +8186,501 @@
                 <a:ea typeface="Inter" pitchFamily="34" charset="-122"/>
                 <a:cs typeface="Inter" pitchFamily="34" charset="-120"/>
               </a:rPr>
-              <a:t>You approve this exact diff. Nothing ships without you.</a:t>
-            </a:r>
-            <a:endParaRPr lang="en-US" sz="1800" dirty="0"/>
-          </a:p>
-        </p:txBody>
-      </p:sp>
-      <p:sp>
-        <p:nvSpPr>
-          <p:cNvPr id="53" name="Text 5 copy 53"/>
-          <p:cNvSpPr/>
-          <p:nvPr/>
-        </p:nvSpPr>
-        <p:spPr>
-          <a:xfrm>
-            <a:off x="812800" y="5500000"/>
-            <a:ext cx="10566400" cy="300000"/>
-          </a:xfrm>
-          <a:prstGeom prst="rect">
-            <a:avLst/>
-          </a:prstGeom>
-          <a:noFill/>
-          <a:ln/>
-        </p:spPr>
-        <p:txBody>
-          <a:bodyPr wrap="square" lIns="0" tIns="0" rIns="0" bIns="0" rtlCol="0" anchor="t">
-            <a:normAutofit/>
-          </a:bodyPr>
-          <a:lstStyle/>
-          <a:p>
-            <a:pPr algn="l" indent="0" marL="0">
-              <a:lnSpc>
-                <a:spcPts val="1400"/>
-              </a:lnSpc>
-              <a:buNone/>
-            </a:pPr>
-            <a:r>
-              <a:rPr lang="en-US" sz="1100" dirty="0">
+              <a:t>Safe upgrades, clear reports</a:t>
+            </a:r>
+            <a:endParaRPr lang="en-US" sz="1350" dirty="0"/>
+          </a:p>
+        </p:txBody>
+      </p:sp>
+      <p:sp>
+        <p:nvSpPr>
+          <p:cNvPr id="55" name="Text 5 copy 55"/>
+          <p:cNvSpPr/>
+          <p:nvPr/>
+        </p:nvSpPr>
+        <p:spPr>
+          <a:xfrm>
+            <a:off x="7358582" y="3450000"/>
+            <a:ext cx="4020618" cy="420000"/>
+          </a:xfrm>
+          <a:prstGeom prst="rect">
+            <a:avLst/>
+          </a:prstGeom>
+          <a:noFill/>
+          <a:ln/>
+        </p:spPr>
+        <p:txBody>
+          <a:bodyPr wrap="square" lIns="0" tIns="0" rIns="0" bIns="0" rtlCol="0" anchor="t">
+            <a:normAutofit/>
+          </a:bodyPr>
+          <a:lstStyle/>
+          <a:p>
+            <a:pPr algn="l" indent="0" marL="0">
+              <a:lnSpc>
+                <a:spcPts val="1250"/>
+              </a:lnSpc>
+              <a:buNone/>
+            </a:pPr>
+            <a:r>
+              <a:rPr lang="en-US" sz="1000" dirty="0" b="0">
+                <a:solidFill>
+                  <a:srgbClr val="A89C92"/>
+                </a:solidFill>
+                <a:latin typeface="Inter" pitchFamily="34" charset="0"/>
+                <a:ea typeface="Inter" pitchFamily="34" charset="-122"/>
+                <a:cs typeface="Inter" pitchFamily="34" charset="-120"/>
+              </a:rPr>
+              <a:t>For vulnerable packages, SupplyGuard suggests compatible upgrades and exports an SBOM and a SARIF report.</a:t>
+            </a:r>
+            <a:endParaRPr lang="en-US" sz="1000" dirty="0"/>
+          </a:p>
+        </p:txBody>
+      </p:sp>
+      <p:sp>
+        <p:nvSpPr>
+          <p:cNvPr id="56" name="Text 5 copy 56"/>
+          <p:cNvSpPr/>
+          <p:nvPr/>
+        </p:nvSpPr>
+        <p:spPr>
+          <a:xfrm>
+            <a:off x="6938582" y="3900000"/>
+            <a:ext cx="300000" cy="300000"/>
+          </a:xfrm>
+          <a:prstGeom prst="ellipse">
+            <a:avLst/>
+          </a:prstGeom>
+          <a:solidFill>
+            <a:srgbClr val="E8652B"/>
+          </a:solidFill>
+          <a:ln w="19050">
+            <a:solidFill>
+              <a:srgbClr val="0E0B09"/>
+            </a:solidFill>
+          </a:ln>
+        </p:spPr>
+        <p:txBody>
+          <a:bodyPr wrap="none" lIns="0" tIns="0" rIns="0" bIns="0" rtlCol="0" anchor="ctr">
+            <a:normAutofit/>
+          </a:bodyPr>
+          <a:lstStyle/>
+          <a:p>
+            <a:pPr algn="ctr" indent="0" marL="0">
+              <a:lnSpc>
+                <a:spcPts val="1440"/>
+              </a:lnSpc>
+              <a:buNone/>
+            </a:pPr>
+            <a:r>
+              <a:rPr lang="en-US" sz="1200" dirty="0" b="1">
+                <a:solidFill>
+                  <a:srgbClr val="F2EDE8"/>
+                </a:solidFill>
+                <a:latin typeface="Inter" pitchFamily="34" charset="0"/>
+                <a:ea typeface="Inter" pitchFamily="34" charset="-122"/>
+                <a:cs typeface="Inter" pitchFamily="34" charset="-120"/>
+              </a:rPr>
+              <a:t>4</a:t>
+            </a:r>
+            <a:endParaRPr lang="en-US" sz="1200" dirty="0"/>
+          </a:p>
+        </p:txBody>
+      </p:sp>
+      <p:sp>
+        <p:nvSpPr>
+          <p:cNvPr id="57" name="Text 5 copy 57"/>
+          <p:cNvSpPr/>
+          <p:nvPr/>
+        </p:nvSpPr>
+        <p:spPr>
+          <a:xfrm>
+            <a:off x="7358582" y="3890000"/>
+            <a:ext cx="4020618" cy="260000"/>
+          </a:xfrm>
+          <a:prstGeom prst="rect">
+            <a:avLst/>
+          </a:prstGeom>
+          <a:noFill/>
+          <a:ln/>
+        </p:spPr>
+        <p:txBody>
+          <a:bodyPr wrap="square" lIns="0" tIns="0" rIns="0" bIns="0" rtlCol="0" anchor="t">
+            <a:normAutofit/>
+          </a:bodyPr>
+          <a:lstStyle/>
+          <a:p>
+            <a:pPr algn="l" indent="0" marL="0">
+              <a:lnSpc>
+                <a:spcPts val="1600"/>
+              </a:lnSpc>
+              <a:buNone/>
+            </a:pPr>
+            <a:r>
+              <a:rPr lang="en-US" sz="1350" dirty="0" b="1">
+                <a:solidFill>
+                  <a:srgbClr val="F2EDE8"/>
+                </a:solidFill>
+                <a:latin typeface="Inter" pitchFamily="34" charset="0"/>
+                <a:ea typeface="Inter" pitchFamily="34" charset="-122"/>
+                <a:cs typeface="Inter" pitchFamily="34" charset="-120"/>
+              </a:rPr>
+              <a:t>Locked-down sandbox</a:t>
+            </a:r>
+            <a:endParaRPr lang="en-US" sz="1350" dirty="0"/>
+          </a:p>
+        </p:txBody>
+      </p:sp>
+      <p:sp>
+        <p:nvSpPr>
+          <p:cNvPr id="58" name="Text 5 copy 58"/>
+          <p:cNvSpPr/>
+          <p:nvPr/>
+        </p:nvSpPr>
+        <p:spPr>
+          <a:xfrm>
+            <a:off x="7358582" y="4140000"/>
+            <a:ext cx="4020618" cy="420000"/>
+          </a:xfrm>
+          <a:prstGeom prst="rect">
+            <a:avLst/>
+          </a:prstGeom>
+          <a:noFill/>
+          <a:ln/>
+        </p:spPr>
+        <p:txBody>
+          <a:bodyPr wrap="square" lIns="0" tIns="0" rIns="0" bIns="0" rtlCol="0" anchor="t">
+            <a:normAutofit/>
+          </a:bodyPr>
+          <a:lstStyle/>
+          <a:p>
+            <a:pPr algn="l" indent="0" marL="0">
+              <a:lnSpc>
+                <a:spcPts val="1250"/>
+              </a:lnSpc>
+              <a:buNone/>
+            </a:pPr>
+            <a:r>
+              <a:rPr lang="en-US" sz="1000" dirty="0" b="0">
+                <a:solidFill>
+                  <a:srgbClr val="A89C92"/>
+                </a:solidFill>
+                <a:latin typeface="Inter" pitchFamily="34" charset="0"/>
+                <a:ea typeface="Inter" pitchFamily="34" charset="-122"/>
+                <a:cs typeface="Inter" pitchFamily="34" charset="-120"/>
+              </a:rPr>
+              <a:t>Repository code runs with no network and no credentials, in a fresh container for every step.</a:t>
+            </a:r>
+            <a:endParaRPr lang="en-US" sz="1000" dirty="0"/>
+          </a:p>
+        </p:txBody>
+      </p:sp>
+      <p:sp>
+        <p:nvSpPr>
+          <p:cNvPr id="59" name="Text 5 copy 59"/>
+          <p:cNvSpPr/>
+          <p:nvPr/>
+        </p:nvSpPr>
+        <p:spPr>
+          <a:xfrm>
+            <a:off x="6938582" y="4590000"/>
+            <a:ext cx="300000" cy="300000"/>
+          </a:xfrm>
+          <a:prstGeom prst="ellipse">
+            <a:avLst/>
+          </a:prstGeom>
+          <a:solidFill>
+            <a:srgbClr val="E8652B"/>
+          </a:solidFill>
+          <a:ln w="19050">
+            <a:solidFill>
+              <a:srgbClr val="0E0B09"/>
+            </a:solidFill>
+          </a:ln>
+        </p:spPr>
+        <p:txBody>
+          <a:bodyPr wrap="none" lIns="0" tIns="0" rIns="0" bIns="0" rtlCol="0" anchor="ctr">
+            <a:normAutofit/>
+          </a:bodyPr>
+          <a:lstStyle/>
+          <a:p>
+            <a:pPr algn="ctr" indent="0" marL="0">
+              <a:lnSpc>
+                <a:spcPts val="1440"/>
+              </a:lnSpc>
+              <a:buNone/>
+            </a:pPr>
+            <a:r>
+              <a:rPr lang="en-US" sz="1200" dirty="0" b="1">
+                <a:solidFill>
+                  <a:srgbClr val="F2EDE8"/>
+                </a:solidFill>
+                <a:latin typeface="Inter" pitchFamily="34" charset="0"/>
+                <a:ea typeface="Inter" pitchFamily="34" charset="-122"/>
+                <a:cs typeface="Inter" pitchFamily="34" charset="-120"/>
+              </a:rPr>
+              <a:t>5</a:t>
+            </a:r>
+            <a:endParaRPr lang="en-US" sz="1200" dirty="0"/>
+          </a:p>
+        </p:txBody>
+      </p:sp>
+      <p:sp>
+        <p:nvSpPr>
+          <p:cNvPr id="60" name="Text 5 copy 60"/>
+          <p:cNvSpPr/>
+          <p:nvPr/>
+        </p:nvSpPr>
+        <p:spPr>
+          <a:xfrm>
+            <a:off x="7358582" y="4580000"/>
+            <a:ext cx="4020618" cy="260000"/>
+          </a:xfrm>
+          <a:prstGeom prst="rect">
+            <a:avLst/>
+          </a:prstGeom>
+          <a:noFill/>
+          <a:ln/>
+        </p:spPr>
+        <p:txBody>
+          <a:bodyPr wrap="square" lIns="0" tIns="0" rIns="0" bIns="0" rtlCol="0" anchor="t">
+            <a:normAutofit/>
+          </a:bodyPr>
+          <a:lstStyle/>
+          <a:p>
+            <a:pPr algn="l" indent="0" marL="0">
+              <a:lnSpc>
+                <a:spcPts val="1600"/>
+              </a:lnSpc>
+              <a:buNone/>
+            </a:pPr>
+            <a:r>
+              <a:rPr lang="en-US" sz="1350" dirty="0" b="1">
+                <a:solidFill>
+                  <a:srgbClr val="F2EDE8"/>
+                </a:solidFill>
+                <a:latin typeface="Inter" pitchFamily="34" charset="0"/>
+                <a:ea typeface="Inter" pitchFamily="34" charset="-122"/>
+                <a:cs typeface="Inter" pitchFamily="34" charset="-120"/>
+              </a:rPr>
+              <a:t>Checks the AI can't fake</a:t>
+            </a:r>
+            <a:endParaRPr lang="en-US" sz="1350" dirty="0"/>
+          </a:p>
+        </p:txBody>
+      </p:sp>
+      <p:sp>
+        <p:nvSpPr>
+          <p:cNvPr id="61" name="Text 5 copy 61"/>
+          <p:cNvSpPr/>
+          <p:nvPr/>
+        </p:nvSpPr>
+        <p:spPr>
+          <a:xfrm>
+            <a:off x="7358582" y="4830000"/>
+            <a:ext cx="4020618" cy="420000"/>
+          </a:xfrm>
+          <a:prstGeom prst="rect">
+            <a:avLst/>
+          </a:prstGeom>
+          <a:noFill/>
+          <a:ln/>
+        </p:spPr>
+        <p:txBody>
+          <a:bodyPr wrap="square" lIns="0" tIns="0" rIns="0" bIns="0" rtlCol="0" anchor="t">
+            <a:normAutofit/>
+          </a:bodyPr>
+          <a:lstStyle/>
+          <a:p>
+            <a:pPr algn="l" indent="0" marL="0">
+              <a:lnSpc>
+                <a:spcPts val="1250"/>
+              </a:lnSpc>
+              <a:buNone/>
+            </a:pPr>
+            <a:r>
+              <a:rPr lang="en-US" sz="1000" dirty="0" b="0">
+                <a:solidFill>
+                  <a:srgbClr val="A89C92"/>
+                </a:solidFill>
+                <a:latin typeface="Inter" pitchFamily="34" charset="0"/>
+                <a:ea typeface="Inter" pitchFamily="34" charset="-122"/>
+                <a:cs typeface="Inter" pitchFamily="34" charset="-120"/>
+              </a:rPr>
+              <a:t>A hidden test the fixer never saw, and a code review that flags shortcuts and swallowed errors.</a:t>
+            </a:r>
+            <a:endParaRPr lang="en-US" sz="1000" dirty="0"/>
+          </a:p>
+        </p:txBody>
+      </p:sp>
+      <p:sp>
+        <p:nvSpPr>
+          <p:cNvPr id="62" name="Text 5 copy 62"/>
+          <p:cNvSpPr/>
+          <p:nvPr/>
+        </p:nvSpPr>
+        <p:spPr>
+          <a:xfrm>
+            <a:off x="6938582" y="5280000"/>
+            <a:ext cx="300000" cy="300000"/>
+          </a:xfrm>
+          <a:prstGeom prst="ellipse">
+            <a:avLst/>
+          </a:prstGeom>
+          <a:solidFill>
+            <a:srgbClr val="E8652B"/>
+          </a:solidFill>
+          <a:ln w="19050">
+            <a:solidFill>
+              <a:srgbClr val="0E0B09"/>
+            </a:solidFill>
+          </a:ln>
+        </p:spPr>
+        <p:txBody>
+          <a:bodyPr wrap="none" lIns="0" tIns="0" rIns="0" bIns="0" rtlCol="0" anchor="ctr">
+            <a:normAutofit/>
+          </a:bodyPr>
+          <a:lstStyle/>
+          <a:p>
+            <a:pPr algn="ctr" indent="0" marL="0">
+              <a:lnSpc>
+                <a:spcPts val="1440"/>
+              </a:lnSpc>
+              <a:buNone/>
+            </a:pPr>
+            <a:r>
+              <a:rPr lang="en-US" sz="1200" dirty="0" b="1">
+                <a:solidFill>
+                  <a:srgbClr val="F2EDE8"/>
+                </a:solidFill>
+                <a:latin typeface="Inter" pitchFamily="34" charset="0"/>
+                <a:ea typeface="Inter" pitchFamily="34" charset="-122"/>
+                <a:cs typeface="Inter" pitchFamily="34" charset="-120"/>
+              </a:rPr>
+              <a:t>6</a:t>
+            </a:r>
+            <a:endParaRPr lang="en-US" sz="1200" dirty="0"/>
+          </a:p>
+        </p:txBody>
+      </p:sp>
+      <p:sp>
+        <p:nvSpPr>
+          <p:cNvPr id="63" name="Text 5 copy 63"/>
+          <p:cNvSpPr/>
+          <p:nvPr/>
+        </p:nvSpPr>
+        <p:spPr>
+          <a:xfrm>
+            <a:off x="7358582" y="5270000"/>
+            <a:ext cx="4020618" cy="260000"/>
+          </a:xfrm>
+          <a:prstGeom prst="rect">
+            <a:avLst/>
+          </a:prstGeom>
+          <a:noFill/>
+          <a:ln/>
+        </p:spPr>
+        <p:txBody>
+          <a:bodyPr wrap="square" lIns="0" tIns="0" rIns="0" bIns="0" rtlCol="0" anchor="t">
+            <a:normAutofit/>
+          </a:bodyPr>
+          <a:lstStyle/>
+          <a:p>
+            <a:pPr algn="l" indent="0" marL="0">
+              <a:lnSpc>
+                <a:spcPts val="1600"/>
+              </a:lnSpc>
+              <a:buNone/>
+            </a:pPr>
+            <a:r>
+              <a:rPr lang="en-US" sz="1350" dirty="0" b="1">
+                <a:solidFill>
+                  <a:srgbClr val="F2EDE8"/>
+                </a:solidFill>
+                <a:latin typeface="Inter" pitchFamily="34" charset="0"/>
+                <a:ea typeface="Inter" pitchFamily="34" charset="-122"/>
+                <a:cs typeface="Inter" pitchFamily="34" charset="-120"/>
+              </a:rPr>
+              <a:t>You stay in control</a:t>
+            </a:r>
+            <a:endParaRPr lang="en-US" sz="1350" dirty="0"/>
+          </a:p>
+        </p:txBody>
+      </p:sp>
+      <p:sp>
+        <p:nvSpPr>
+          <p:cNvPr id="64" name="Text 5 copy 64"/>
+          <p:cNvSpPr/>
+          <p:nvPr/>
+        </p:nvSpPr>
+        <p:spPr>
+          <a:xfrm>
+            <a:off x="7358582" y="5520000"/>
+            <a:ext cx="4020618" cy="420000"/>
+          </a:xfrm>
+          <a:prstGeom prst="rect">
+            <a:avLst/>
+          </a:prstGeom>
+          <a:noFill/>
+          <a:ln/>
+        </p:spPr>
+        <p:txBody>
+          <a:bodyPr wrap="square" lIns="0" tIns="0" rIns="0" bIns="0" rtlCol="0" anchor="t">
+            <a:normAutofit/>
+          </a:bodyPr>
+          <a:lstStyle/>
+          <a:p>
+            <a:pPr algn="l" indent="0" marL="0">
+              <a:lnSpc>
+                <a:spcPts val="1250"/>
+              </a:lnSpc>
+              <a:buNone/>
+            </a:pPr>
+            <a:r>
+              <a:rPr lang="en-US" sz="1000" dirty="0" b="0">
+                <a:solidFill>
+                  <a:srgbClr val="A89C92"/>
+                </a:solidFill>
+                <a:latin typeface="Inter" pitchFamily="34" charset="0"/>
+                <a:ea typeface="Inter" pitchFamily="34" charset="-122"/>
+                <a:cs typeface="Inter" pitchFamily="34" charset="-120"/>
+              </a:rPr>
+              <a:t>You approve the exact diff before a draft PR opens. If a fix can't be proven, you get an honest report.</a:t>
+            </a:r>
+            <a:endParaRPr lang="en-US" sz="1000" dirty="0"/>
+          </a:p>
+        </p:txBody>
+      </p:sp>
+      <p:sp>
+        <p:nvSpPr>
+          <p:cNvPr id="65" name="Text 5 copy 65"/>
+          <p:cNvSpPr/>
+          <p:nvPr/>
+        </p:nvSpPr>
+        <p:spPr>
+          <a:xfrm>
+            <a:off x="812800" y="4830000"/>
+            <a:ext cx="5675782" cy="420000"/>
+          </a:xfrm>
+          <a:prstGeom prst="rect">
+            <a:avLst/>
+          </a:prstGeom>
+          <a:noFill/>
+          <a:ln/>
+        </p:spPr>
+        <p:txBody>
+          <a:bodyPr wrap="square" lIns="0" tIns="0" rIns="0" bIns="0" rtlCol="0" anchor="t">
+            <a:normAutofit/>
+          </a:bodyPr>
+          <a:lstStyle/>
+          <a:p>
+            <a:pPr algn="l" indent="0" marL="0">
+              <a:lnSpc>
+                <a:spcPts val="1350"/>
+              </a:lnSpc>
+              <a:buNone/>
+            </a:pPr>
+            <a:r>
+              <a:rPr lang="en-US" sz="1050" dirty="0">
                 <a:solidFill>
                   <a:srgbClr val="E8652B"/>
                 </a:solidFill>
@@ -8136,9 +8688,9 @@
                 <a:ea typeface="JetBrains Mono" pitchFamily="49" charset="-122"/>
                 <a:cs typeface="JetBrains Mono" pitchFamily="49" charset="-120"/>
               </a:rPr>
-              <a:t>Live today: 3 of 3 planted bugs fixed, 2-7 min each  ·  2 real draft PRs opened (tinycalc #4, #5)</a:t>
-            </a:r>
-            <a:endParaRPr lang="en-US" sz="1100" dirty="0"/>
+              <a:t>Live today: 3 of 3 planted bugs fixed, 2-7 min each. 2 real draft PRs opened (tinycalc #4, #5).</a:t>
+            </a:r>
+            <a:endParaRPr lang="en-US" sz="1050" dirty="0"/>
           </a:p>
         </p:txBody>
       </p:sp>

</xml_diff>